<commit_message>
Carrusel PPTX: los huecos de cartas, logo y sprites como imágenes, para que Canva las sustituya al arrastrar
Co-Authored-By: Claude Fable 5.1 <noreply@anthropic.com>
Claude-Session: https://claude.ai/code/session_01SJQkm3gTKwBC1nx4r9bYD9
</commit_message>
<xml_diff>
--- a/assets/redes/pokedoc-carrusel.pptx
+++ b/assets/redes/pokedoc-carrusel.pptx
@@ -2912,33 +2912,28 @@
           </a:p>
         </p:txBody>
       </p:sp>
-      <p:sp>
-        <p:nvSpPr>
-          <p:cNvPr id="9" name="Shape 7"/>
-          <p:cNvSpPr/>
-          <p:nvPr/>
-        </p:nvSpPr>
+      <p:pic>
+        <p:nvPicPr>
+          <p:cNvPr id="9" name="Image 0" descr="/tmp/claude-0/-home-user/b9afdd5d-e7a3-5d00-bfc6-d85d45049058/scratchpad/canva/hueco-carta.png">    </p:cNvPr>
+          <p:cNvPicPr>
+            <a:picLocks noChangeAspect="1"/>
+          </p:cNvPicPr>
+          <p:nvPr/>
+        </p:nvPicPr>
+        <p:blipFill>
+          <a:blip r:embed="rId2"/>
+          <a:stretch>
+            <a:fillRect/>
+          </a:stretch>
+        </p:blipFill>
         <p:spPr>
           <a:xfrm>
             <a:off x="990600" y="7715250"/>
             <a:ext cx="1947863" cy="2720824"/>
           </a:xfrm>
-          <a:prstGeom prst="roundRect">
-            <a:avLst>
-              <a:gd name="adj" fmla="val 6846"/>
-            </a:avLst>
-          </a:prstGeom>
-          <a:solidFill>
-            <a:srgbClr val="E1F0F4"/>
-          </a:solidFill>
-          <a:ln w="12700">
-            <a:solidFill>
-              <a:srgbClr val="E1F0F4">
-                <a:alpha val="0"/>
-              </a:srgbClr>
-            </a:solidFill>
-            <a:prstDash val="solid"/>
-          </a:ln>
+          <a:prstGeom prst="rect">
+            <a:avLst/>
+          </a:prstGeom>
           <a:effectLst>
             <a:outerShdw sx="100000" sy="100000" kx="0" ky="0" algn="bl" rotWithShape="0" blurRad="152400" dist="76200" dir="5400000">
               <a:srgbClr val="000000">
@@ -2947,52 +2942,10 @@
             </a:outerShdw>
           </a:effectLst>
         </p:spPr>
-      </p:sp>
-      <p:sp>
-        <p:nvSpPr>
-          <p:cNvPr id="10" name="Text 8"/>
-          <p:cNvSpPr txBox="1"/>
-          <p:nvPr/>
-        </p:nvSpPr>
-        <p:spPr>
-          <a:xfrm>
-            <a:off x="990600" y="7715250"/>
-            <a:ext cx="1947863" cy="2720824"/>
-          </a:xfrm>
-          <a:prstGeom prst="rect">
-            <a:avLst/>
-          </a:prstGeom>
-          <a:noFill/>
-          <a:ln/>
-        </p:spPr>
-        <p:txBody>
-          <a:bodyPr wrap="square" lIns="0" tIns="0" rIns="0" bIns="0" rtlCol="0" anchor="ctr"/>
-          <a:lstStyle/>
-          <a:p>
-            <a:pPr algn="ctr" indent="0" marL="0">
-              <a:lnSpc>
-                <a:spcPct val="115000"/>
-              </a:lnSpc>
-              <a:buNone/>
-            </a:pPr>
-            <a:r>
-              <a:rPr lang="en-US" sz="1700" dirty="0">
-                <a:solidFill>
-                  <a:srgbClr val="52717F"/>
-                </a:solidFill>
-                <a:latin typeface="Inter" pitchFamily="34" charset="0"/>
-                <a:ea typeface="Inter" pitchFamily="34" charset="-122"/>
-                <a:cs typeface="Inter" pitchFamily="34" charset="-120"/>
-              </a:rPr>
-              <a:t>Carta 1</a:t>
-            </a:r>
-            <a:endParaRPr lang="en-US" sz="1700" dirty="0"/>
-          </a:p>
-        </p:txBody>
-      </p:sp>
-      <p:sp>
-        <p:nvSpPr>
-          <p:cNvPr id="11" name="Shape 9"/>
+      </p:pic>
+      <p:sp>
+        <p:nvSpPr>
+          <p:cNvPr id="10" name="Shape 7"/>
           <p:cNvSpPr/>
           <p:nvPr/>
         </p:nvSpPr>
@@ -3021,7 +2974,7 @@
       </p:sp>
       <p:sp>
         <p:nvSpPr>
-          <p:cNvPr id="12" name="Text 10"/>
+          <p:cNvPr id="11" name="Text 8"/>
           <p:cNvSpPr txBox="1"/>
           <p:nvPr/>
         </p:nvSpPr>
@@ -3061,33 +3014,28 @@
           </a:p>
         </p:txBody>
       </p:sp>
-      <p:sp>
-        <p:nvSpPr>
-          <p:cNvPr id="13" name="Shape 11"/>
-          <p:cNvSpPr/>
-          <p:nvPr/>
-        </p:nvSpPr>
+      <p:pic>
+        <p:nvPicPr>
+          <p:cNvPr id="12" name="Image 1" descr="/tmp/claude-0/-home-user/b9afdd5d-e7a3-5d00-bfc6-d85d45049058/scratchpad/canva/hueco-carta.png">    </p:cNvPr>
+          <p:cNvPicPr>
+            <a:picLocks noChangeAspect="1"/>
+          </p:cNvPicPr>
+          <p:nvPr/>
+        </p:nvPicPr>
+        <p:blipFill>
+          <a:blip r:embed="rId3"/>
+          <a:stretch>
+            <a:fillRect/>
+          </a:stretch>
+        </p:blipFill>
         <p:spPr>
           <a:xfrm>
             <a:off x="3109913" y="7715250"/>
             <a:ext cx="1947863" cy="2720824"/>
           </a:xfrm>
-          <a:prstGeom prst="roundRect">
-            <a:avLst>
-              <a:gd name="adj" fmla="val 6846"/>
-            </a:avLst>
-          </a:prstGeom>
-          <a:solidFill>
-            <a:srgbClr val="E1F0F4"/>
-          </a:solidFill>
-          <a:ln w="12700">
-            <a:solidFill>
-              <a:srgbClr val="E1F0F4">
-                <a:alpha val="0"/>
-              </a:srgbClr>
-            </a:solidFill>
-            <a:prstDash val="solid"/>
-          </a:ln>
+          <a:prstGeom prst="rect">
+            <a:avLst/>
+          </a:prstGeom>
           <a:effectLst>
             <a:outerShdw sx="100000" sy="100000" kx="0" ky="0" algn="bl" rotWithShape="0" blurRad="152400" dist="76200" dir="5400000">
               <a:srgbClr val="000000">
@@ -3096,52 +3044,10 @@
             </a:outerShdw>
           </a:effectLst>
         </p:spPr>
-      </p:sp>
-      <p:sp>
-        <p:nvSpPr>
-          <p:cNvPr id="14" name="Text 12"/>
-          <p:cNvSpPr txBox="1"/>
-          <p:nvPr/>
-        </p:nvSpPr>
-        <p:spPr>
-          <a:xfrm>
-            <a:off x="3109913" y="7715250"/>
-            <a:ext cx="1947863" cy="2720824"/>
-          </a:xfrm>
-          <a:prstGeom prst="rect">
-            <a:avLst/>
-          </a:prstGeom>
-          <a:noFill/>
-          <a:ln/>
-        </p:spPr>
-        <p:txBody>
-          <a:bodyPr wrap="square" lIns="0" tIns="0" rIns="0" bIns="0" rtlCol="0" anchor="ctr"/>
-          <a:lstStyle/>
-          <a:p>
-            <a:pPr algn="ctr" indent="0" marL="0">
-              <a:lnSpc>
-                <a:spcPct val="115000"/>
-              </a:lnSpc>
-              <a:buNone/>
-            </a:pPr>
-            <a:r>
-              <a:rPr lang="en-US" sz="1700" dirty="0">
-                <a:solidFill>
-                  <a:srgbClr val="52717F"/>
-                </a:solidFill>
-                <a:latin typeface="Inter" pitchFamily="34" charset="0"/>
-                <a:ea typeface="Inter" pitchFamily="34" charset="-122"/>
-                <a:cs typeface="Inter" pitchFamily="34" charset="-120"/>
-              </a:rPr>
-              <a:t>Carta 2</a:t>
-            </a:r>
-            <a:endParaRPr lang="en-US" sz="1700" dirty="0"/>
-          </a:p>
-        </p:txBody>
-      </p:sp>
-      <p:sp>
-        <p:nvSpPr>
-          <p:cNvPr id="15" name="Shape 13"/>
+      </p:pic>
+      <p:sp>
+        <p:nvSpPr>
+          <p:cNvPr id="13" name="Shape 9"/>
           <p:cNvSpPr/>
           <p:nvPr/>
         </p:nvSpPr>
@@ -3170,7 +3076,7 @@
       </p:sp>
       <p:sp>
         <p:nvSpPr>
-          <p:cNvPr id="16" name="Text 14"/>
+          <p:cNvPr id="14" name="Text 10"/>
           <p:cNvSpPr txBox="1"/>
           <p:nvPr/>
         </p:nvSpPr>
@@ -3210,33 +3116,28 @@
           </a:p>
         </p:txBody>
       </p:sp>
-      <p:sp>
-        <p:nvSpPr>
-          <p:cNvPr id="17" name="Shape 15"/>
-          <p:cNvSpPr/>
-          <p:nvPr/>
-        </p:nvSpPr>
+      <p:pic>
+        <p:nvPicPr>
+          <p:cNvPr id="15" name="Image 2" descr="/tmp/claude-0/-home-user/b9afdd5d-e7a3-5d00-bfc6-d85d45049058/scratchpad/canva/hueco-carta.png">    </p:cNvPr>
+          <p:cNvPicPr>
+            <a:picLocks noChangeAspect="1"/>
+          </p:cNvPicPr>
+          <p:nvPr/>
+        </p:nvPicPr>
+        <p:blipFill>
+          <a:blip r:embed="rId4"/>
+          <a:stretch>
+            <a:fillRect/>
+          </a:stretch>
+        </p:blipFill>
         <p:spPr>
           <a:xfrm>
             <a:off x="5229225" y="7715250"/>
             <a:ext cx="1947863" cy="2720824"/>
           </a:xfrm>
-          <a:prstGeom prst="roundRect">
-            <a:avLst>
-              <a:gd name="adj" fmla="val 6846"/>
-            </a:avLst>
-          </a:prstGeom>
-          <a:solidFill>
-            <a:srgbClr val="E1F0F4"/>
-          </a:solidFill>
-          <a:ln w="12700">
-            <a:solidFill>
-              <a:srgbClr val="E1F0F4">
-                <a:alpha val="0"/>
-              </a:srgbClr>
-            </a:solidFill>
-            <a:prstDash val="solid"/>
-          </a:ln>
+          <a:prstGeom prst="rect">
+            <a:avLst/>
+          </a:prstGeom>
           <a:effectLst>
             <a:outerShdw sx="100000" sy="100000" kx="0" ky="0" algn="bl" rotWithShape="0" blurRad="152400" dist="76200" dir="5400000">
               <a:srgbClr val="000000">
@@ -3245,52 +3146,10 @@
             </a:outerShdw>
           </a:effectLst>
         </p:spPr>
-      </p:sp>
-      <p:sp>
-        <p:nvSpPr>
-          <p:cNvPr id="18" name="Text 16"/>
-          <p:cNvSpPr txBox="1"/>
-          <p:nvPr/>
-        </p:nvSpPr>
-        <p:spPr>
-          <a:xfrm>
-            <a:off x="5229225" y="7715250"/>
-            <a:ext cx="1947863" cy="2720824"/>
-          </a:xfrm>
-          <a:prstGeom prst="rect">
-            <a:avLst/>
-          </a:prstGeom>
-          <a:noFill/>
-          <a:ln/>
-        </p:spPr>
-        <p:txBody>
-          <a:bodyPr wrap="square" lIns="0" tIns="0" rIns="0" bIns="0" rtlCol="0" anchor="ctr"/>
-          <a:lstStyle/>
-          <a:p>
-            <a:pPr algn="ctr" indent="0" marL="0">
-              <a:lnSpc>
-                <a:spcPct val="115000"/>
-              </a:lnSpc>
-              <a:buNone/>
-            </a:pPr>
-            <a:r>
-              <a:rPr lang="en-US" sz="1700" dirty="0">
-                <a:solidFill>
-                  <a:srgbClr val="52717F"/>
-                </a:solidFill>
-                <a:latin typeface="Inter" pitchFamily="34" charset="0"/>
-                <a:ea typeface="Inter" pitchFamily="34" charset="-122"/>
-                <a:cs typeface="Inter" pitchFamily="34" charset="-120"/>
-              </a:rPr>
-              <a:t>Carta 3</a:t>
-            </a:r>
-            <a:endParaRPr lang="en-US" sz="1700" dirty="0"/>
-          </a:p>
-        </p:txBody>
-      </p:sp>
-      <p:sp>
-        <p:nvSpPr>
-          <p:cNvPr id="19" name="Shape 17"/>
+      </p:pic>
+      <p:sp>
+        <p:nvSpPr>
+          <p:cNvPr id="16" name="Shape 11"/>
           <p:cNvSpPr/>
           <p:nvPr/>
         </p:nvSpPr>
@@ -3319,7 +3178,7 @@
       </p:sp>
       <p:sp>
         <p:nvSpPr>
-          <p:cNvPr id="20" name="Text 18"/>
+          <p:cNvPr id="17" name="Text 12"/>
           <p:cNvSpPr txBox="1"/>
           <p:nvPr/>
         </p:nvSpPr>
@@ -3359,33 +3218,28 @@
           </a:p>
         </p:txBody>
       </p:sp>
-      <p:sp>
-        <p:nvSpPr>
-          <p:cNvPr id="21" name="Shape 19"/>
-          <p:cNvSpPr/>
-          <p:nvPr/>
-        </p:nvSpPr>
+      <p:pic>
+        <p:nvPicPr>
+          <p:cNvPr id="18" name="Image 3" descr="/tmp/claude-0/-home-user/b9afdd5d-e7a3-5d00-bfc6-d85d45049058/scratchpad/canva/hueco-carta.png">    </p:cNvPr>
+          <p:cNvPicPr>
+            <a:picLocks noChangeAspect="1"/>
+          </p:cNvPicPr>
+          <p:nvPr/>
+        </p:nvPicPr>
+        <p:blipFill>
+          <a:blip r:embed="rId5"/>
+          <a:stretch>
+            <a:fillRect/>
+          </a:stretch>
+        </p:blipFill>
         <p:spPr>
           <a:xfrm>
             <a:off x="7348538" y="7715250"/>
             <a:ext cx="1947863" cy="2720824"/>
           </a:xfrm>
-          <a:prstGeom prst="roundRect">
-            <a:avLst>
-              <a:gd name="adj" fmla="val 6846"/>
-            </a:avLst>
-          </a:prstGeom>
-          <a:solidFill>
-            <a:srgbClr val="E1F0F4"/>
-          </a:solidFill>
-          <a:ln w="12700">
-            <a:solidFill>
-              <a:srgbClr val="E1F0F4">
-                <a:alpha val="0"/>
-              </a:srgbClr>
-            </a:solidFill>
-            <a:prstDash val="solid"/>
-          </a:ln>
+          <a:prstGeom prst="rect">
+            <a:avLst/>
+          </a:prstGeom>
           <a:effectLst>
             <a:outerShdw sx="100000" sy="100000" kx="0" ky="0" algn="bl" rotWithShape="0" blurRad="152400" dist="76200" dir="5400000">
               <a:srgbClr val="000000">
@@ -3394,52 +3248,10 @@
             </a:outerShdw>
           </a:effectLst>
         </p:spPr>
-      </p:sp>
-      <p:sp>
-        <p:nvSpPr>
-          <p:cNvPr id="22" name="Text 20"/>
-          <p:cNvSpPr txBox="1"/>
-          <p:nvPr/>
-        </p:nvSpPr>
-        <p:spPr>
-          <a:xfrm>
-            <a:off x="7348538" y="7715250"/>
-            <a:ext cx="1947863" cy="2720824"/>
-          </a:xfrm>
-          <a:prstGeom prst="rect">
-            <a:avLst/>
-          </a:prstGeom>
-          <a:noFill/>
-          <a:ln/>
-        </p:spPr>
-        <p:txBody>
-          <a:bodyPr wrap="square" lIns="0" tIns="0" rIns="0" bIns="0" rtlCol="0" anchor="ctr"/>
-          <a:lstStyle/>
-          <a:p>
-            <a:pPr algn="ctr" indent="0" marL="0">
-              <a:lnSpc>
-                <a:spcPct val="115000"/>
-              </a:lnSpc>
-              <a:buNone/>
-            </a:pPr>
-            <a:r>
-              <a:rPr lang="en-US" sz="1700" dirty="0">
-                <a:solidFill>
-                  <a:srgbClr val="52717F"/>
-                </a:solidFill>
-                <a:latin typeface="Inter" pitchFamily="34" charset="0"/>
-                <a:ea typeface="Inter" pitchFamily="34" charset="-122"/>
-                <a:cs typeface="Inter" pitchFamily="34" charset="-120"/>
-              </a:rPr>
-              <a:t>Carta 4</a:t>
-            </a:r>
-            <a:endParaRPr lang="en-US" sz="1700" dirty="0"/>
-          </a:p>
-        </p:txBody>
-      </p:sp>
-      <p:sp>
-        <p:nvSpPr>
-          <p:cNvPr id="23" name="Shape 21"/>
+      </p:pic>
+      <p:sp>
+        <p:nvSpPr>
+          <p:cNvPr id="19" name="Shape 13"/>
           <p:cNvSpPr/>
           <p:nvPr/>
         </p:nvSpPr>
@@ -3468,7 +3280,7 @@
       </p:sp>
       <p:sp>
         <p:nvSpPr>
-          <p:cNvPr id="24" name="Text 22"/>
+          <p:cNvPr id="20" name="Text 14"/>
           <p:cNvSpPr txBox="1"/>
           <p:nvPr/>
         </p:nvSpPr>
@@ -3510,7 +3322,7 @@
       </p:sp>
       <p:sp>
         <p:nvSpPr>
-          <p:cNvPr id="25" name="Text 23"/>
+          <p:cNvPr id="21" name="Text 15"/>
           <p:cNvSpPr txBox="1"/>
           <p:nvPr/>
         </p:nvSpPr>
@@ -3552,7 +3364,7 @@
       </p:sp>
       <p:sp>
         <p:nvSpPr>
-          <p:cNvPr id="26" name="Shape 24"/>
+          <p:cNvPr id="22" name="Shape 16"/>
           <p:cNvSpPr/>
           <p:nvPr/>
         </p:nvSpPr>
@@ -3581,7 +3393,7 @@
       </p:sp>
       <p:sp>
         <p:nvSpPr>
-          <p:cNvPr id="27" name="Text 25"/>
+          <p:cNvPr id="23" name="Text 17"/>
           <p:cNvSpPr txBox="1"/>
           <p:nvPr/>
         </p:nvSpPr>
@@ -3874,146 +3686,28 @@
           </a:effectLst>
         </p:spPr>
       </p:sp>
-      <p:sp>
-        <p:nvSpPr>
-          <p:cNvPr id="6" name="Shape 4"/>
-          <p:cNvSpPr/>
-          <p:nvPr/>
-        </p:nvSpPr>
+      <p:pic>
+        <p:nvPicPr>
+          <p:cNvPr id="6" name="Image 0" descr="/tmp/claude-0/-home-user/b9afdd5d-e7a3-5d00-bfc6-d85d45049058/scratchpad/canva/hueco-logo.png">    </p:cNvPr>
+          <p:cNvPicPr>
+            <a:picLocks noChangeAspect="1"/>
+          </p:cNvPicPr>
+          <p:nvPr/>
+        </p:nvPicPr>
+        <p:blipFill>
+          <a:blip r:embed="rId2"/>
+          <a:stretch>
+            <a:fillRect/>
+          </a:stretch>
+        </p:blipFill>
         <p:spPr>
           <a:xfrm>
             <a:off x="990600" y="6438900"/>
             <a:ext cx="2857500" cy="1047750"/>
           </a:xfrm>
-          <a:prstGeom prst="roundRect">
-            <a:avLst>
-              <a:gd name="adj" fmla="val 14545"/>
-            </a:avLst>
-          </a:prstGeom>
-          <a:solidFill>
-            <a:srgbClr val="E1F0F4"/>
-          </a:solidFill>
-          <a:ln w="12700">
-            <a:solidFill>
-              <a:srgbClr val="E1F0F4">
-                <a:alpha val="0"/>
-              </a:srgbClr>
-            </a:solidFill>
-            <a:prstDash val="solid"/>
-          </a:ln>
-        </p:spPr>
-      </p:sp>
-      <p:sp>
-        <p:nvSpPr>
-          <p:cNvPr id="7" name="Text 5"/>
-          <p:cNvSpPr txBox="1"/>
-          <p:nvPr/>
-        </p:nvSpPr>
-        <p:spPr>
-          <a:xfrm>
-            <a:off x="990600" y="6438900"/>
-            <a:ext cx="2857500" cy="1047750"/>
-          </a:xfrm>
-          <a:prstGeom prst="rect">
-            <a:avLst/>
-          </a:prstGeom>
-          <a:noFill/>
-          <a:ln/>
-        </p:spPr>
-        <p:txBody>
-          <a:bodyPr wrap="square" lIns="0" tIns="0" rIns="0" bIns="0" rtlCol="0" anchor="ctr"/>
-          <a:lstStyle/>
-          <a:p>
-            <a:pPr algn="ctr" indent="0" marL="0">
-              <a:lnSpc>
-                <a:spcPct val="115000"/>
-              </a:lnSpc>
-              <a:buNone/>
-            </a:pPr>
-            <a:r>
-              <a:rPr lang="en-US" sz="1700" dirty="0">
-                <a:solidFill>
-                  <a:srgbClr val="52717F"/>
-                </a:solidFill>
-                <a:latin typeface="Inter" pitchFamily="34" charset="0"/>
-                <a:ea typeface="Inter" pitchFamily="34" charset="-122"/>
-                <a:cs typeface="Inter" pitchFamily="34" charset="-120"/>
-              </a:rPr>
-              <a:t>Logo del set</a:t>
-            </a:r>
-            <a:endParaRPr lang="en-US" sz="1700" dirty="0"/>
-          </a:p>
-        </p:txBody>
-      </p:sp>
-      <p:sp>
-        <p:nvSpPr>
-          <p:cNvPr id="8" name="Text 6"/>
-          <p:cNvSpPr txBox="1"/>
-          <p:nvPr/>
-        </p:nvSpPr>
-        <p:spPr>
-          <a:xfrm>
-            <a:off x="5486400" y="6781800"/>
-            <a:ext cx="3810000" cy="342900"/>
-          </a:xfrm>
-          <a:prstGeom prst="rect">
-            <a:avLst/>
-          </a:prstGeom>
-          <a:noFill/>
-          <a:ln/>
-        </p:spPr>
-        <p:txBody>
-          <a:bodyPr wrap="square" lIns="0" tIns="0" rIns="0" bIns="0" rtlCol="0" anchor="t"/>
-          <a:lstStyle/>
-          <a:p>
-            <a:pPr algn="r" indent="0" marL="0">
-              <a:lnSpc>
-                <a:spcPct val="115000"/>
-              </a:lnSpc>
-              <a:buNone/>
-            </a:pPr>
-            <a:r>
-              <a:rPr lang="en-US" sz="2000" b="1" dirty="0">
-                <a:solidFill>
-                  <a:srgbClr val="52717F"/>
-                </a:solidFill>
-                <a:latin typeface="Inter" pitchFamily="34" charset="0"/>
-                <a:ea typeface="Inter" pitchFamily="34" charset="-122"/>
-                <a:cs typeface="Inter" pitchFamily="34" charset="-120"/>
-              </a:rPr>
-              <a:t>141 de 193 · 72 %</a:t>
-            </a:r>
-            <a:endParaRPr lang="en-US" sz="2000" dirty="0"/>
-          </a:p>
-        </p:txBody>
-      </p:sp>
-      <p:sp>
-        <p:nvSpPr>
-          <p:cNvPr id="9" name="Shape 7"/>
-          <p:cNvSpPr/>
-          <p:nvPr/>
-        </p:nvSpPr>
-        <p:spPr>
-          <a:xfrm>
-            <a:off x="990600" y="7810500"/>
-            <a:ext cx="1947863" cy="2720824"/>
-          </a:xfrm>
-          <a:prstGeom prst="roundRect">
-            <a:avLst>
-              <a:gd name="adj" fmla="val 6846"/>
-            </a:avLst>
-          </a:prstGeom>
-          <a:solidFill>
-            <a:srgbClr val="E1F0F4"/>
-          </a:solidFill>
-          <a:ln w="12700">
-            <a:solidFill>
-              <a:srgbClr val="E1F0F4">
-                <a:alpha val="0"/>
-              </a:srgbClr>
-            </a:solidFill>
-            <a:prstDash val="solid"/>
-          </a:ln>
+          <a:prstGeom prst="rect">
+            <a:avLst/>
+          </a:prstGeom>
           <a:effectLst>
             <a:outerShdw sx="100000" sy="100000" kx="0" ky="0" algn="bl" rotWithShape="0" blurRad="152400" dist="76200" dir="5400000">
               <a:srgbClr val="000000">
@@ -4022,13 +3716,63 @@
             </a:outerShdw>
           </a:effectLst>
         </p:spPr>
-      </p:sp>
-      <p:sp>
-        <p:nvSpPr>
-          <p:cNvPr id="10" name="Text 8"/>
-          <p:cNvSpPr txBox="1"/>
-          <p:nvPr/>
-        </p:nvSpPr>
+      </p:pic>
+      <p:sp>
+        <p:nvSpPr>
+          <p:cNvPr id="7" name="Text 4"/>
+          <p:cNvSpPr txBox="1"/>
+          <p:nvPr/>
+        </p:nvSpPr>
+        <p:spPr>
+          <a:xfrm>
+            <a:off x="5486400" y="6781800"/>
+            <a:ext cx="3810000" cy="342900"/>
+          </a:xfrm>
+          <a:prstGeom prst="rect">
+            <a:avLst/>
+          </a:prstGeom>
+          <a:noFill/>
+          <a:ln/>
+        </p:spPr>
+        <p:txBody>
+          <a:bodyPr wrap="square" lIns="0" tIns="0" rIns="0" bIns="0" rtlCol="0" anchor="t"/>
+          <a:lstStyle/>
+          <a:p>
+            <a:pPr algn="r" indent="0" marL="0">
+              <a:lnSpc>
+                <a:spcPct val="115000"/>
+              </a:lnSpc>
+              <a:buNone/>
+            </a:pPr>
+            <a:r>
+              <a:rPr lang="en-US" sz="2000" b="1" dirty="0">
+                <a:solidFill>
+                  <a:srgbClr val="52717F"/>
+                </a:solidFill>
+                <a:latin typeface="Inter" pitchFamily="34" charset="0"/>
+                <a:ea typeface="Inter" pitchFamily="34" charset="-122"/>
+                <a:cs typeface="Inter" pitchFamily="34" charset="-120"/>
+              </a:rPr>
+              <a:t>141 de 193 · 72 %</a:t>
+            </a:r>
+            <a:endParaRPr lang="en-US" sz="2000" dirty="0"/>
+          </a:p>
+        </p:txBody>
+      </p:sp>
+      <p:pic>
+        <p:nvPicPr>
+          <p:cNvPr id="8" name="Image 1" descr="/tmp/claude-0/-home-user/b9afdd5d-e7a3-5d00-bfc6-d85d45049058/scratchpad/canva/hueco-carta.png">    </p:cNvPr>
+          <p:cNvPicPr>
+            <a:picLocks noChangeAspect="1"/>
+          </p:cNvPicPr>
+          <p:nvPr/>
+        </p:nvPicPr>
+        <p:blipFill>
+          <a:blip r:embed="rId3"/>
+          <a:stretch>
+            <a:fillRect/>
+          </a:stretch>
+        </p:blipFill>
         <p:spPr>
           <a:xfrm>
             <a:off x="990600" y="7810500"/>
@@ -4037,61 +3781,6 @@
           <a:prstGeom prst="rect">
             <a:avLst/>
           </a:prstGeom>
-          <a:noFill/>
-          <a:ln/>
-        </p:spPr>
-        <p:txBody>
-          <a:bodyPr wrap="square" lIns="0" tIns="0" rIns="0" bIns="0" rtlCol="0" anchor="ctr"/>
-          <a:lstStyle/>
-          <a:p>
-            <a:pPr algn="ctr" indent="0" marL="0">
-              <a:lnSpc>
-                <a:spcPct val="115000"/>
-              </a:lnSpc>
-              <a:buNone/>
-            </a:pPr>
-            <a:r>
-              <a:rPr lang="en-US" sz="1700" dirty="0">
-                <a:solidFill>
-                  <a:srgbClr val="52717F"/>
-                </a:solidFill>
-                <a:latin typeface="Inter" pitchFamily="34" charset="0"/>
-                <a:ea typeface="Inter" pitchFamily="34" charset="-122"/>
-                <a:cs typeface="Inter" pitchFamily="34" charset="-120"/>
-              </a:rPr>
-              <a:t>Carta 1</a:t>
-            </a:r>
-            <a:endParaRPr lang="en-US" sz="1700" dirty="0"/>
-          </a:p>
-        </p:txBody>
-      </p:sp>
-      <p:sp>
-        <p:nvSpPr>
-          <p:cNvPr id="11" name="Shape 9"/>
-          <p:cNvSpPr/>
-          <p:nvPr/>
-        </p:nvSpPr>
-        <p:spPr>
-          <a:xfrm>
-            <a:off x="3109913" y="7810500"/>
-            <a:ext cx="1947863" cy="2720824"/>
-          </a:xfrm>
-          <a:prstGeom prst="roundRect">
-            <a:avLst>
-              <a:gd name="adj" fmla="val 6846"/>
-            </a:avLst>
-          </a:prstGeom>
-          <a:solidFill>
-            <a:srgbClr val="E1F0F4"/>
-          </a:solidFill>
-          <a:ln w="12700">
-            <a:solidFill>
-              <a:srgbClr val="E1F0F4">
-                <a:alpha val="0"/>
-              </a:srgbClr>
-            </a:solidFill>
-            <a:prstDash val="solid"/>
-          </a:ln>
           <a:effectLst>
             <a:outerShdw sx="100000" sy="100000" kx="0" ky="0" algn="bl" rotWithShape="0" blurRad="152400" dist="76200" dir="5400000">
               <a:srgbClr val="000000">
@@ -4100,13 +3789,21 @@
             </a:outerShdw>
           </a:effectLst>
         </p:spPr>
-      </p:sp>
-      <p:sp>
-        <p:nvSpPr>
-          <p:cNvPr id="12" name="Text 10"/>
-          <p:cNvSpPr txBox="1"/>
-          <p:nvPr/>
-        </p:nvSpPr>
+      </p:pic>
+      <p:pic>
+        <p:nvPicPr>
+          <p:cNvPr id="9" name="Image 2" descr="/tmp/claude-0/-home-user/b9afdd5d-e7a3-5d00-bfc6-d85d45049058/scratchpad/canva/hueco-carta.png">    </p:cNvPr>
+          <p:cNvPicPr>
+            <a:picLocks noChangeAspect="1"/>
+          </p:cNvPicPr>
+          <p:nvPr/>
+        </p:nvPicPr>
+        <p:blipFill>
+          <a:blip r:embed="rId4"/>
+          <a:stretch>
+            <a:fillRect/>
+          </a:stretch>
+        </p:blipFill>
         <p:spPr>
           <a:xfrm>
             <a:off x="3109913" y="7810500"/>
@@ -4115,61 +3812,6 @@
           <a:prstGeom prst="rect">
             <a:avLst/>
           </a:prstGeom>
-          <a:noFill/>
-          <a:ln/>
-        </p:spPr>
-        <p:txBody>
-          <a:bodyPr wrap="square" lIns="0" tIns="0" rIns="0" bIns="0" rtlCol="0" anchor="ctr"/>
-          <a:lstStyle/>
-          <a:p>
-            <a:pPr algn="ctr" indent="0" marL="0">
-              <a:lnSpc>
-                <a:spcPct val="115000"/>
-              </a:lnSpc>
-              <a:buNone/>
-            </a:pPr>
-            <a:r>
-              <a:rPr lang="en-US" sz="1700" dirty="0">
-                <a:solidFill>
-                  <a:srgbClr val="52717F"/>
-                </a:solidFill>
-                <a:latin typeface="Inter" pitchFamily="34" charset="0"/>
-                <a:ea typeface="Inter" pitchFamily="34" charset="-122"/>
-                <a:cs typeface="Inter" pitchFamily="34" charset="-120"/>
-              </a:rPr>
-              <a:t>Carta 2</a:t>
-            </a:r>
-            <a:endParaRPr lang="en-US" sz="1700" dirty="0"/>
-          </a:p>
-        </p:txBody>
-      </p:sp>
-      <p:sp>
-        <p:nvSpPr>
-          <p:cNvPr id="13" name="Shape 11"/>
-          <p:cNvSpPr/>
-          <p:nvPr/>
-        </p:nvSpPr>
-        <p:spPr>
-          <a:xfrm>
-            <a:off x="5229225" y="7810500"/>
-            <a:ext cx="1947863" cy="2720824"/>
-          </a:xfrm>
-          <a:prstGeom prst="roundRect">
-            <a:avLst>
-              <a:gd name="adj" fmla="val 6846"/>
-            </a:avLst>
-          </a:prstGeom>
-          <a:solidFill>
-            <a:srgbClr val="E1F0F4"/>
-          </a:solidFill>
-          <a:ln w="12700">
-            <a:solidFill>
-              <a:srgbClr val="E1F0F4">
-                <a:alpha val="0"/>
-              </a:srgbClr>
-            </a:solidFill>
-            <a:prstDash val="solid"/>
-          </a:ln>
           <a:effectLst>
             <a:outerShdw sx="100000" sy="100000" kx="0" ky="0" algn="bl" rotWithShape="0" blurRad="152400" dist="76200" dir="5400000">
               <a:srgbClr val="000000">
@@ -4178,13 +3820,21 @@
             </a:outerShdw>
           </a:effectLst>
         </p:spPr>
-      </p:sp>
-      <p:sp>
-        <p:nvSpPr>
-          <p:cNvPr id="14" name="Text 12"/>
-          <p:cNvSpPr txBox="1"/>
-          <p:nvPr/>
-        </p:nvSpPr>
+      </p:pic>
+      <p:pic>
+        <p:nvPicPr>
+          <p:cNvPr id="10" name="Image 3" descr="/tmp/claude-0/-home-user/b9afdd5d-e7a3-5d00-bfc6-d85d45049058/scratchpad/canva/hueco-carta.png">    </p:cNvPr>
+          <p:cNvPicPr>
+            <a:picLocks noChangeAspect="1"/>
+          </p:cNvPicPr>
+          <p:nvPr/>
+        </p:nvPicPr>
+        <p:blipFill>
+          <a:blip r:embed="rId5"/>
+          <a:stretch>
+            <a:fillRect/>
+          </a:stretch>
+        </p:blipFill>
         <p:spPr>
           <a:xfrm>
             <a:off x="5229225" y="7810500"/>
@@ -4193,61 +3843,6 @@
           <a:prstGeom prst="rect">
             <a:avLst/>
           </a:prstGeom>
-          <a:noFill/>
-          <a:ln/>
-        </p:spPr>
-        <p:txBody>
-          <a:bodyPr wrap="square" lIns="0" tIns="0" rIns="0" bIns="0" rtlCol="0" anchor="ctr"/>
-          <a:lstStyle/>
-          <a:p>
-            <a:pPr algn="ctr" indent="0" marL="0">
-              <a:lnSpc>
-                <a:spcPct val="115000"/>
-              </a:lnSpc>
-              <a:buNone/>
-            </a:pPr>
-            <a:r>
-              <a:rPr lang="en-US" sz="1700" dirty="0">
-                <a:solidFill>
-                  <a:srgbClr val="52717F"/>
-                </a:solidFill>
-                <a:latin typeface="Inter" pitchFamily="34" charset="0"/>
-                <a:ea typeface="Inter" pitchFamily="34" charset="-122"/>
-                <a:cs typeface="Inter" pitchFamily="34" charset="-120"/>
-              </a:rPr>
-              <a:t>Carta 3</a:t>
-            </a:r>
-            <a:endParaRPr lang="en-US" sz="1700" dirty="0"/>
-          </a:p>
-        </p:txBody>
-      </p:sp>
-      <p:sp>
-        <p:nvSpPr>
-          <p:cNvPr id="15" name="Shape 13"/>
-          <p:cNvSpPr/>
-          <p:nvPr/>
-        </p:nvSpPr>
-        <p:spPr>
-          <a:xfrm>
-            <a:off x="7348538" y="7810500"/>
-            <a:ext cx="1947863" cy="2720824"/>
-          </a:xfrm>
-          <a:prstGeom prst="roundRect">
-            <a:avLst>
-              <a:gd name="adj" fmla="val 6846"/>
-            </a:avLst>
-          </a:prstGeom>
-          <a:solidFill>
-            <a:srgbClr val="E1F0F4"/>
-          </a:solidFill>
-          <a:ln w="12700">
-            <a:solidFill>
-              <a:srgbClr val="E1F0F4">
-                <a:alpha val="0"/>
-              </a:srgbClr>
-            </a:solidFill>
-            <a:prstDash val="solid"/>
-          </a:ln>
           <a:effectLst>
             <a:outerShdw sx="100000" sy="100000" kx="0" ky="0" algn="bl" rotWithShape="0" blurRad="152400" dist="76200" dir="5400000">
               <a:srgbClr val="000000">
@@ -4256,13 +3851,21 @@
             </a:outerShdw>
           </a:effectLst>
         </p:spPr>
-      </p:sp>
-      <p:sp>
-        <p:nvSpPr>
-          <p:cNvPr id="16" name="Text 14"/>
-          <p:cNvSpPr txBox="1"/>
-          <p:nvPr/>
-        </p:nvSpPr>
+      </p:pic>
+      <p:pic>
+        <p:nvPicPr>
+          <p:cNvPr id="11" name="Image 4" descr="/tmp/claude-0/-home-user/b9afdd5d-e7a3-5d00-bfc6-d85d45049058/scratchpad/canva/hueco-carta.png">    </p:cNvPr>
+          <p:cNvPicPr>
+            <a:picLocks noChangeAspect="1"/>
+          </p:cNvPicPr>
+          <p:nvPr/>
+        </p:nvPicPr>
+        <p:blipFill>
+          <a:blip r:embed="rId6"/>
+          <a:stretch>
+            <a:fillRect/>
+          </a:stretch>
+        </p:blipFill>
         <p:spPr>
           <a:xfrm>
             <a:off x="7348538" y="7810500"/>
@@ -4271,37 +3874,18 @@
           <a:prstGeom prst="rect">
             <a:avLst/>
           </a:prstGeom>
-          <a:noFill/>
-          <a:ln/>
-        </p:spPr>
-        <p:txBody>
-          <a:bodyPr wrap="square" lIns="0" tIns="0" rIns="0" bIns="0" rtlCol="0" anchor="ctr"/>
-          <a:lstStyle/>
-          <a:p>
-            <a:pPr algn="ctr" indent="0" marL="0">
-              <a:lnSpc>
-                <a:spcPct val="115000"/>
-              </a:lnSpc>
-              <a:buNone/>
-            </a:pPr>
-            <a:r>
-              <a:rPr lang="en-US" sz="1700" dirty="0">
-                <a:solidFill>
-                  <a:srgbClr val="52717F"/>
-                </a:solidFill>
-                <a:latin typeface="Inter" pitchFamily="34" charset="0"/>
-                <a:ea typeface="Inter" pitchFamily="34" charset="-122"/>
-                <a:cs typeface="Inter" pitchFamily="34" charset="-120"/>
-              </a:rPr>
-              <a:t>Carta 4</a:t>
-            </a:r>
-            <a:endParaRPr lang="en-US" sz="1700" dirty="0"/>
-          </a:p>
-        </p:txBody>
-      </p:sp>
-      <p:sp>
-        <p:nvSpPr>
-          <p:cNvPr id="17" name="Text 15"/>
+          <a:effectLst>
+            <a:outerShdw sx="100000" sy="100000" kx="0" ky="0" algn="bl" rotWithShape="0" blurRad="152400" dist="76200" dir="5400000">
+              <a:srgbClr val="000000">
+                <a:alpha val="25000"/>
+              </a:srgbClr>
+            </a:outerShdw>
+          </a:effectLst>
+        </p:spPr>
+      </p:pic>
+      <p:sp>
+        <p:nvSpPr>
+          <p:cNvPr id="12" name="Text 5"/>
           <p:cNvSpPr txBox="1"/>
           <p:nvPr/>
         </p:nvSpPr>
@@ -4343,7 +3927,7 @@
       </p:sp>
       <p:sp>
         <p:nvSpPr>
-          <p:cNvPr id="18" name="Shape 16"/>
+          <p:cNvPr id="13" name="Shape 6"/>
           <p:cNvSpPr/>
           <p:nvPr/>
         </p:nvSpPr>
@@ -4372,7 +3956,7 @@
       </p:sp>
       <p:sp>
         <p:nvSpPr>
-          <p:cNvPr id="19" name="Text 17"/>
+          <p:cNvPr id="14" name="Text 7"/>
           <p:cNvSpPr txBox="1"/>
           <p:nvPr/>
         </p:nvSpPr>
@@ -5716,33 +5300,28 @@
           </a:p>
         </p:txBody>
       </p:sp>
-      <p:sp>
-        <p:nvSpPr>
-          <p:cNvPr id="11" name="Shape 9"/>
-          <p:cNvSpPr/>
-          <p:nvPr/>
-        </p:nvSpPr>
+      <p:pic>
+        <p:nvPicPr>
+          <p:cNvPr id="11" name="Image 0" descr="/tmp/claude-0/-home-user/b9afdd5d-e7a3-5d00-bfc6-d85d45049058/scratchpad/canva/hueco-carta-hilo.png">    </p:cNvPr>
+          <p:cNvPicPr>
+            <a:picLocks noChangeAspect="1"/>
+          </p:cNvPicPr>
+          <p:nvPr/>
+        </p:nvPicPr>
+        <p:blipFill>
+          <a:blip r:embed="rId2"/>
+          <a:stretch>
+            <a:fillRect/>
+          </a:stretch>
+        </p:blipFill>
         <p:spPr>
           <a:xfrm>
             <a:off x="7524750" y="6667500"/>
             <a:ext cx="2095500" cy="2924175"/>
           </a:xfrm>
-          <a:prstGeom prst="roundRect">
-            <a:avLst>
-              <a:gd name="adj" fmla="val 6364"/>
-            </a:avLst>
-          </a:prstGeom>
-          <a:solidFill>
-            <a:srgbClr val="E1F0F4"/>
-          </a:solidFill>
-          <a:ln w="12700">
-            <a:solidFill>
-              <a:srgbClr val="E1F0F4">
-                <a:alpha val="0"/>
-              </a:srgbClr>
-            </a:solidFill>
-            <a:prstDash val="solid"/>
-          </a:ln>
+          <a:prstGeom prst="rect">
+            <a:avLst/>
+          </a:prstGeom>
           <a:effectLst>
             <a:outerShdw sx="100000" sy="100000" kx="0" ky="0" algn="bl" rotWithShape="0" blurRad="152400" dist="76200" dir="5400000">
               <a:srgbClr val="000000">
@@ -5751,52 +5330,10 @@
             </a:outerShdw>
           </a:effectLst>
         </p:spPr>
-      </p:sp>
-      <p:sp>
-        <p:nvSpPr>
-          <p:cNvPr id="12" name="Text 10"/>
-          <p:cNvSpPr txBox="1"/>
-          <p:nvPr/>
-        </p:nvSpPr>
-        <p:spPr>
-          <a:xfrm>
-            <a:off x="7524750" y="6667500"/>
-            <a:ext cx="2095500" cy="2924175"/>
-          </a:xfrm>
-          <a:prstGeom prst="rect">
-            <a:avLst/>
-          </a:prstGeom>
-          <a:noFill/>
-          <a:ln/>
-        </p:spPr>
-        <p:txBody>
-          <a:bodyPr wrap="square" lIns="0" tIns="0" rIns="0" bIns="0" rtlCol="0" anchor="ctr"/>
-          <a:lstStyle/>
-          <a:p>
-            <a:pPr algn="ctr" indent="0" marL="0">
-              <a:lnSpc>
-                <a:spcPct val="115000"/>
-              </a:lnSpc>
-              <a:buNone/>
-            </a:pPr>
-            <a:r>
-              <a:rPr lang="en-US" sz="1700" dirty="0">
-                <a:solidFill>
-                  <a:srgbClr val="52717F"/>
-                </a:solidFill>
-                <a:latin typeface="Inter" pitchFamily="34" charset="0"/>
-                <a:ea typeface="Inter" pitchFamily="34" charset="-122"/>
-                <a:cs typeface="Inter" pitchFamily="34" charset="-120"/>
-              </a:rPr>
-              <a:t>Carta del hilo</a:t>
-            </a:r>
-            <a:endParaRPr lang="en-US" sz="1700" dirty="0"/>
-          </a:p>
-        </p:txBody>
-      </p:sp>
-      <p:sp>
-        <p:nvSpPr>
-          <p:cNvPr id="13" name="Text 11"/>
+      </p:pic>
+      <p:sp>
+        <p:nvSpPr>
+          <p:cNvPr id="12" name="Text 9"/>
           <p:cNvSpPr txBox="1"/>
           <p:nvPr/>
         </p:nvSpPr>
@@ -5838,7 +5375,7 @@
       </p:sp>
       <p:sp>
         <p:nvSpPr>
-          <p:cNvPr id="14" name="Shape 12"/>
+          <p:cNvPr id="13" name="Shape 10"/>
           <p:cNvSpPr/>
           <p:nvPr/>
         </p:nvSpPr>
@@ -5867,7 +5404,7 @@
       </p:sp>
       <p:sp>
         <p:nvSpPr>
-          <p:cNvPr id="15" name="Text 13"/>
+          <p:cNvPr id="14" name="Text 11"/>
           <p:cNvSpPr txBox="1"/>
           <p:nvPr/>
         </p:nvSpPr>
@@ -6155,33 +5692,28 @@
           </a:ln>
         </p:spPr>
       </p:sp>
-      <p:sp>
-        <p:nvSpPr>
-          <p:cNvPr id="6" name="Shape 4"/>
-          <p:cNvSpPr/>
-          <p:nvPr/>
-        </p:nvSpPr>
+      <p:pic>
+        <p:nvPicPr>
+          <p:cNvPr id="6" name="Image 0" descr="/tmp/claude-0/-home-user/b9afdd5d-e7a3-5d00-bfc6-d85d45049058/scratchpad/canva/hueco-silueta.png">    </p:cNvPr>
+          <p:cNvPicPr>
+            <a:picLocks noChangeAspect="1"/>
+          </p:cNvPicPr>
+          <p:nvPr/>
+        </p:nvPicPr>
+        <p:blipFill>
+          <a:blip r:embed="rId2"/>
+          <a:stretch>
+            <a:fillRect/>
+          </a:stretch>
+        </p:blipFill>
         <p:spPr>
           <a:xfrm>
             <a:off x="1428750" y="7162800"/>
             <a:ext cx="2286000" cy="3190875"/>
           </a:xfrm>
-          <a:prstGeom prst="roundRect">
-            <a:avLst>
-              <a:gd name="adj" fmla="val 5833"/>
-            </a:avLst>
-          </a:prstGeom>
-          <a:solidFill>
-            <a:srgbClr val="E1F0F4"/>
-          </a:solidFill>
-          <a:ln w="12700">
-            <a:solidFill>
-              <a:srgbClr val="E1F0F4">
-                <a:alpha val="0"/>
-              </a:srgbClr>
-            </a:solidFill>
-            <a:prstDash val="solid"/>
-          </a:ln>
+          <a:prstGeom prst="rect">
+            <a:avLst/>
+          </a:prstGeom>
           <a:effectLst>
             <a:outerShdw sx="100000" sy="100000" kx="0" ky="0" algn="bl" rotWithShape="0" blurRad="152400" dist="76200" dir="5400000">
               <a:srgbClr val="000000">
@@ -6190,52 +5722,10 @@
             </a:outerShdw>
           </a:effectLst>
         </p:spPr>
-      </p:sp>
-      <p:sp>
-        <p:nvSpPr>
-          <p:cNvPr id="7" name="Text 5"/>
-          <p:cNvSpPr txBox="1"/>
-          <p:nvPr/>
-        </p:nvSpPr>
-        <p:spPr>
-          <a:xfrm>
-            <a:off x="1428750" y="7162800"/>
-            <a:ext cx="2286000" cy="3190875"/>
-          </a:xfrm>
-          <a:prstGeom prst="rect">
-            <a:avLst/>
-          </a:prstGeom>
-          <a:noFill/>
-          <a:ln/>
-        </p:spPr>
-        <p:txBody>
-          <a:bodyPr wrap="square" lIns="0" tIns="0" rIns="0" bIns="0" rtlCol="0" anchor="ctr"/>
-          <a:lstStyle/>
-          <a:p>
-            <a:pPr algn="ctr" indent="0" marL="0">
-              <a:lnSpc>
-                <a:spcPct val="115000"/>
-              </a:lnSpc>
-              <a:buNone/>
-            </a:pPr>
-            <a:r>
-              <a:rPr lang="en-US" sz="1700" dirty="0">
-                <a:solidFill>
-                  <a:srgbClr val="52717F"/>
-                </a:solidFill>
-                <a:latin typeface="Inter" pitchFamily="34" charset="0"/>
-                <a:ea typeface="Inter" pitchFamily="34" charset="-122"/>
-                <a:cs typeface="Inter" pitchFamily="34" charset="-120"/>
-              </a:rPr>
-              <a:t>Silueta de la carta</a:t>
-            </a:r>
-            <a:endParaRPr lang="en-US" sz="1700" dirty="0"/>
-          </a:p>
-        </p:txBody>
-      </p:sp>
-      <p:sp>
-        <p:nvSpPr>
-          <p:cNvPr id="8" name="Text 6"/>
+      </p:pic>
+      <p:sp>
+        <p:nvSpPr>
+          <p:cNvPr id="7" name="Text 4"/>
           <p:cNvSpPr txBox="1"/>
           <p:nvPr/>
         </p:nvSpPr>
@@ -6277,7 +5767,7 @@
       </p:sp>
       <p:sp>
         <p:nvSpPr>
-          <p:cNvPr id="9" name="Text 7"/>
+          <p:cNvPr id="8" name="Text 5"/>
           <p:cNvSpPr txBox="1"/>
           <p:nvPr/>
         </p:nvSpPr>
@@ -6319,7 +5809,7 @@
       </p:sp>
       <p:sp>
         <p:nvSpPr>
-          <p:cNvPr id="10" name="Text 8"/>
+          <p:cNvPr id="9" name="Text 6"/>
           <p:cNvSpPr txBox="1"/>
           <p:nvPr/>
         </p:nvSpPr>
@@ -6361,7 +5851,7 @@
       </p:sp>
       <p:sp>
         <p:nvSpPr>
-          <p:cNvPr id="11" name="Shape 9"/>
+          <p:cNvPr id="10" name="Shape 7"/>
           <p:cNvSpPr/>
           <p:nvPr/>
         </p:nvSpPr>
@@ -6390,7 +5880,7 @@
       </p:sp>
       <p:sp>
         <p:nvSpPr>
-          <p:cNvPr id="12" name="Text 10"/>
+          <p:cNvPr id="11" name="Text 8"/>
           <p:cNvSpPr txBox="1"/>
           <p:nvPr/>
         </p:nvSpPr>
@@ -6432,7 +5922,7 @@
       </p:sp>
       <p:sp>
         <p:nvSpPr>
-          <p:cNvPr id="13" name="Text 11"/>
+          <p:cNvPr id="12" name="Text 9"/>
           <p:cNvSpPr txBox="1"/>
           <p:nvPr/>
         </p:nvSpPr>
@@ -6474,7 +5964,7 @@
       </p:sp>
       <p:sp>
         <p:nvSpPr>
-          <p:cNvPr id="14" name="Shape 12"/>
+          <p:cNvPr id="13" name="Shape 10"/>
           <p:cNvSpPr/>
           <p:nvPr/>
         </p:nvSpPr>
@@ -6503,7 +5993,7 @@
       </p:sp>
       <p:sp>
         <p:nvSpPr>
-          <p:cNvPr id="15" name="Text 13"/>
+          <p:cNvPr id="14" name="Text 11"/>
           <p:cNvSpPr txBox="1"/>
           <p:nvPr/>
         </p:nvSpPr>
@@ -6796,80 +6286,40 @@
           </a:effectLst>
         </p:spPr>
       </p:sp>
-      <p:sp>
-        <p:nvSpPr>
-          <p:cNvPr id="6" name="Shape 4"/>
-          <p:cNvSpPr/>
-          <p:nvPr/>
-        </p:nvSpPr>
+      <p:pic>
+        <p:nvPicPr>
+          <p:cNvPr id="6" name="Image 0" descr="/tmp/claude-0/-home-user/b9afdd5d-e7a3-5d00-bfc6-d85d45049058/scratchpad/canva/hueco-sprite.png">    </p:cNvPr>
+          <p:cNvPicPr>
+            <a:picLocks noChangeAspect="1"/>
+          </p:cNvPicPr>
+          <p:nvPr/>
+        </p:nvPicPr>
+        <p:blipFill>
+          <a:blip r:embed="rId2"/>
+          <a:stretch>
+            <a:fillRect/>
+          </a:stretch>
+        </p:blipFill>
         <p:spPr>
           <a:xfrm>
             <a:off x="2057400" y="7620000"/>
             <a:ext cx="1143000" cy="1143000"/>
           </a:xfrm>
-          <a:prstGeom prst="roundRect">
-            <a:avLst>
-              <a:gd name="adj" fmla="val 50000"/>
-            </a:avLst>
-          </a:prstGeom>
-          <a:solidFill>
-            <a:srgbClr val="E1F0F4"/>
-          </a:solidFill>
-          <a:ln w="12700">
-            <a:solidFill>
-              <a:srgbClr val="E1F0F4">
-                <a:alpha val="0"/>
+          <a:prstGeom prst="rect">
+            <a:avLst/>
+          </a:prstGeom>
+          <a:effectLst>
+            <a:outerShdw sx="100000" sy="100000" kx="0" ky="0" algn="bl" rotWithShape="0" blurRad="152400" dist="76200" dir="5400000">
+              <a:srgbClr val="000000">
+                <a:alpha val="25000"/>
               </a:srgbClr>
-            </a:solidFill>
-            <a:prstDash val="solid"/>
-          </a:ln>
-        </p:spPr>
-      </p:sp>
-      <p:sp>
-        <p:nvSpPr>
-          <p:cNvPr id="7" name="Text 5"/>
-          <p:cNvSpPr txBox="1"/>
-          <p:nvPr/>
-        </p:nvSpPr>
-        <p:spPr>
-          <a:xfrm>
-            <a:off x="2057400" y="7620000"/>
-            <a:ext cx="1143000" cy="1143000"/>
-          </a:xfrm>
-          <a:prstGeom prst="rect">
-            <a:avLst/>
-          </a:prstGeom>
-          <a:noFill/>
-          <a:ln/>
-        </p:spPr>
-        <p:txBody>
-          <a:bodyPr wrap="square" lIns="0" tIns="0" rIns="0" bIns="0" rtlCol="0" anchor="ctr"/>
-          <a:lstStyle/>
-          <a:p>
-            <a:pPr algn="ctr" indent="0" marL="0">
-              <a:lnSpc>
-                <a:spcPct val="115000"/>
-              </a:lnSpc>
-              <a:buNone/>
-            </a:pPr>
-            <a:r>
-              <a:rPr lang="en-US" sz="1500" dirty="0">
-                <a:solidFill>
-                  <a:srgbClr val="52717F"/>
-                </a:solidFill>
-                <a:latin typeface="Inter" pitchFamily="34" charset="0"/>
-                <a:ea typeface="Inter" pitchFamily="34" charset="-122"/>
-                <a:cs typeface="Inter" pitchFamily="34" charset="-120"/>
-              </a:rPr>
-              <a:t>Sprite</a:t>
-            </a:r>
-            <a:endParaRPr lang="en-US" sz="1500" dirty="0"/>
-          </a:p>
-        </p:txBody>
-      </p:sp>
-      <p:sp>
-        <p:nvSpPr>
-          <p:cNvPr id="8" name="Text 6"/>
+            </a:outerShdw>
+          </a:effectLst>
+        </p:spPr>
+      </p:pic>
+      <p:sp>
+        <p:nvSpPr>
+          <p:cNvPr id="7" name="Text 4"/>
           <p:cNvSpPr txBox="1"/>
           <p:nvPr/>
         </p:nvSpPr>
@@ -6911,7 +6361,7 @@
       </p:sp>
       <p:sp>
         <p:nvSpPr>
-          <p:cNvPr id="9" name="Text 7"/>
+          <p:cNvPr id="8" name="Text 5"/>
           <p:cNvSpPr txBox="1"/>
           <p:nvPr/>
         </p:nvSpPr>
@@ -6953,7 +6403,7 @@
       </p:sp>
       <p:sp>
         <p:nvSpPr>
-          <p:cNvPr id="10" name="Shape 8"/>
+          <p:cNvPr id="9" name="Shape 6"/>
           <p:cNvSpPr/>
           <p:nvPr/>
         </p:nvSpPr>
@@ -6987,80 +6437,40 @@
           </a:effectLst>
         </p:spPr>
       </p:sp>
-      <p:sp>
-        <p:nvSpPr>
-          <p:cNvPr id="11" name="Shape 9"/>
-          <p:cNvSpPr/>
-          <p:nvPr/>
-        </p:nvSpPr>
+      <p:pic>
+        <p:nvPicPr>
+          <p:cNvPr id="10" name="Image 1" descr="/tmp/claude-0/-home-user/b9afdd5d-e7a3-5d00-bfc6-d85d45049058/scratchpad/canva/hueco-sprite.png">    </p:cNvPr>
+          <p:cNvPicPr>
+            <a:picLocks noChangeAspect="1"/>
+          </p:cNvPicPr>
+          <p:nvPr/>
+        </p:nvPicPr>
+        <p:blipFill>
+          <a:blip r:embed="rId3"/>
+          <a:stretch>
+            <a:fillRect/>
+          </a:stretch>
+        </p:blipFill>
         <p:spPr>
           <a:xfrm>
             <a:off x="4572000" y="6762750"/>
             <a:ext cx="1143000" cy="1143000"/>
           </a:xfrm>
-          <a:prstGeom prst="roundRect">
-            <a:avLst>
-              <a:gd name="adj" fmla="val 50000"/>
-            </a:avLst>
-          </a:prstGeom>
-          <a:solidFill>
-            <a:srgbClr val="E1F0F4"/>
-          </a:solidFill>
-          <a:ln w="12700">
-            <a:solidFill>
-              <a:srgbClr val="E1F0F4">
-                <a:alpha val="0"/>
+          <a:prstGeom prst="rect">
+            <a:avLst/>
+          </a:prstGeom>
+          <a:effectLst>
+            <a:outerShdw sx="100000" sy="100000" kx="0" ky="0" algn="bl" rotWithShape="0" blurRad="152400" dist="76200" dir="5400000">
+              <a:srgbClr val="000000">
+                <a:alpha val="25000"/>
               </a:srgbClr>
-            </a:solidFill>
-            <a:prstDash val="solid"/>
-          </a:ln>
-        </p:spPr>
-      </p:sp>
-      <p:sp>
-        <p:nvSpPr>
-          <p:cNvPr id="12" name="Text 10"/>
-          <p:cNvSpPr txBox="1"/>
-          <p:nvPr/>
-        </p:nvSpPr>
-        <p:spPr>
-          <a:xfrm>
-            <a:off x="4572000" y="6762750"/>
-            <a:ext cx="1143000" cy="1143000"/>
-          </a:xfrm>
-          <a:prstGeom prst="rect">
-            <a:avLst/>
-          </a:prstGeom>
-          <a:noFill/>
-          <a:ln/>
-        </p:spPr>
-        <p:txBody>
-          <a:bodyPr wrap="square" lIns="0" tIns="0" rIns="0" bIns="0" rtlCol="0" anchor="ctr"/>
-          <a:lstStyle/>
-          <a:p>
-            <a:pPr algn="ctr" indent="0" marL="0">
-              <a:lnSpc>
-                <a:spcPct val="115000"/>
-              </a:lnSpc>
-              <a:buNone/>
-            </a:pPr>
-            <a:r>
-              <a:rPr lang="en-US" sz="1500" dirty="0">
-                <a:solidFill>
-                  <a:srgbClr val="52717F"/>
-                </a:solidFill>
-                <a:latin typeface="Inter" pitchFamily="34" charset="0"/>
-                <a:ea typeface="Inter" pitchFamily="34" charset="-122"/>
-                <a:cs typeface="Inter" pitchFamily="34" charset="-120"/>
-              </a:rPr>
-              <a:t>Sprite</a:t>
-            </a:r>
-            <a:endParaRPr lang="en-US" sz="1500" dirty="0"/>
-          </a:p>
-        </p:txBody>
-      </p:sp>
-      <p:sp>
-        <p:nvSpPr>
-          <p:cNvPr id="13" name="Text 11"/>
+            </a:outerShdw>
+          </a:effectLst>
+        </p:spPr>
+      </p:pic>
+      <p:sp>
+        <p:nvSpPr>
+          <p:cNvPr id="11" name="Text 7"/>
           <p:cNvSpPr txBox="1"/>
           <p:nvPr/>
         </p:nvSpPr>
@@ -7102,7 +6512,7 @@
       </p:sp>
       <p:sp>
         <p:nvSpPr>
-          <p:cNvPr id="14" name="Text 12"/>
+          <p:cNvPr id="12" name="Text 8"/>
           <p:cNvSpPr txBox="1"/>
           <p:nvPr/>
         </p:nvSpPr>
@@ -7144,7 +6554,7 @@
       </p:sp>
       <p:sp>
         <p:nvSpPr>
-          <p:cNvPr id="15" name="Shape 13"/>
+          <p:cNvPr id="13" name="Shape 9"/>
           <p:cNvSpPr/>
           <p:nvPr/>
         </p:nvSpPr>
@@ -7178,80 +6588,40 @@
           </a:effectLst>
         </p:spPr>
       </p:sp>
-      <p:sp>
-        <p:nvSpPr>
-          <p:cNvPr id="16" name="Shape 14"/>
-          <p:cNvSpPr/>
-          <p:nvPr/>
-        </p:nvSpPr>
+      <p:pic>
+        <p:nvPicPr>
+          <p:cNvPr id="14" name="Image 2" descr="/tmp/claude-0/-home-user/b9afdd5d-e7a3-5d00-bfc6-d85d45049058/scratchpad/canva/hueco-sprite.png">    </p:cNvPr>
+          <p:cNvPicPr>
+            <a:picLocks noChangeAspect="1"/>
+          </p:cNvPicPr>
+          <p:nvPr/>
+        </p:nvPicPr>
+        <p:blipFill>
+          <a:blip r:embed="rId4"/>
+          <a:stretch>
+            <a:fillRect/>
+          </a:stretch>
+        </p:blipFill>
         <p:spPr>
           <a:xfrm>
             <a:off x="7086600" y="8191500"/>
             <a:ext cx="1143000" cy="1143000"/>
           </a:xfrm>
-          <a:prstGeom prst="roundRect">
-            <a:avLst>
-              <a:gd name="adj" fmla="val 50000"/>
-            </a:avLst>
-          </a:prstGeom>
-          <a:solidFill>
-            <a:srgbClr val="E1F0F4"/>
-          </a:solidFill>
-          <a:ln w="12700">
-            <a:solidFill>
-              <a:srgbClr val="E1F0F4">
-                <a:alpha val="0"/>
+          <a:prstGeom prst="rect">
+            <a:avLst/>
+          </a:prstGeom>
+          <a:effectLst>
+            <a:outerShdw sx="100000" sy="100000" kx="0" ky="0" algn="bl" rotWithShape="0" blurRad="152400" dist="76200" dir="5400000">
+              <a:srgbClr val="000000">
+                <a:alpha val="25000"/>
               </a:srgbClr>
-            </a:solidFill>
-            <a:prstDash val="solid"/>
-          </a:ln>
-        </p:spPr>
-      </p:sp>
-      <p:sp>
-        <p:nvSpPr>
-          <p:cNvPr id="17" name="Text 15"/>
-          <p:cNvSpPr txBox="1"/>
-          <p:nvPr/>
-        </p:nvSpPr>
-        <p:spPr>
-          <a:xfrm>
-            <a:off x="7086600" y="8191500"/>
-            <a:ext cx="1143000" cy="1143000"/>
-          </a:xfrm>
-          <a:prstGeom prst="rect">
-            <a:avLst/>
-          </a:prstGeom>
-          <a:noFill/>
-          <a:ln/>
-        </p:spPr>
-        <p:txBody>
-          <a:bodyPr wrap="square" lIns="0" tIns="0" rIns="0" bIns="0" rtlCol="0" anchor="ctr"/>
-          <a:lstStyle/>
-          <a:p>
-            <a:pPr algn="ctr" indent="0" marL="0">
-              <a:lnSpc>
-                <a:spcPct val="115000"/>
-              </a:lnSpc>
-              <a:buNone/>
-            </a:pPr>
-            <a:r>
-              <a:rPr lang="en-US" sz="1500" dirty="0">
-                <a:solidFill>
-                  <a:srgbClr val="52717F"/>
-                </a:solidFill>
-                <a:latin typeface="Inter" pitchFamily="34" charset="0"/>
-                <a:ea typeface="Inter" pitchFamily="34" charset="-122"/>
-                <a:cs typeface="Inter" pitchFamily="34" charset="-120"/>
-              </a:rPr>
-              <a:t>Sprite</a:t>
-            </a:r>
-            <a:endParaRPr lang="en-US" sz="1500" dirty="0"/>
-          </a:p>
-        </p:txBody>
-      </p:sp>
-      <p:sp>
-        <p:nvSpPr>
-          <p:cNvPr id="18" name="Text 16"/>
+            </a:outerShdw>
+          </a:effectLst>
+        </p:spPr>
+      </p:pic>
+      <p:sp>
+        <p:nvSpPr>
+          <p:cNvPr id="15" name="Text 10"/>
           <p:cNvSpPr txBox="1"/>
           <p:nvPr/>
         </p:nvSpPr>
@@ -7293,7 +6663,7 @@
       </p:sp>
       <p:sp>
         <p:nvSpPr>
-          <p:cNvPr id="19" name="Text 17"/>
+          <p:cNvPr id="16" name="Text 11"/>
           <p:cNvSpPr txBox="1"/>
           <p:nvPr/>
         </p:nvSpPr>
@@ -7335,7 +6705,7 @@
       </p:sp>
       <p:sp>
         <p:nvSpPr>
-          <p:cNvPr id="20" name="Text 18"/>
+          <p:cNvPr id="17" name="Text 12"/>
           <p:cNvSpPr txBox="1"/>
           <p:nvPr/>
         </p:nvSpPr>
@@ -7377,7 +6747,7 @@
       </p:sp>
       <p:sp>
         <p:nvSpPr>
-          <p:cNvPr id="21" name="Shape 19"/>
+          <p:cNvPr id="18" name="Shape 13"/>
           <p:cNvSpPr/>
           <p:nvPr/>
         </p:nvSpPr>
@@ -7406,7 +6776,7 @@
       </p:sp>
       <p:sp>
         <p:nvSpPr>
-          <p:cNvPr id="22" name="Text 20"/>
+          <p:cNvPr id="19" name="Text 14"/>
           <p:cNvSpPr txBox="1"/>
           <p:nvPr/>
         </p:nvSpPr>
@@ -8038,33 +7408,28 @@
           </a:p>
         </p:txBody>
       </p:sp>
-      <p:sp>
-        <p:nvSpPr>
-          <p:cNvPr id="15" name="Shape 13"/>
-          <p:cNvSpPr/>
-          <p:nvPr/>
-        </p:nvSpPr>
+      <p:pic>
+        <p:nvPicPr>
+          <p:cNvPr id="15" name="Image 0" descr="/tmp/claude-0/-home-user/b9afdd5d-e7a3-5d00-bfc6-d85d45049058/scratchpad/canva/hueco-carta.png">    </p:cNvPr>
+          <p:cNvPicPr>
+            <a:picLocks noChangeAspect="1"/>
+          </p:cNvPicPr>
+          <p:nvPr/>
+        </p:nvPicPr>
+        <p:blipFill>
+          <a:blip r:embed="rId2"/>
+          <a:stretch>
+            <a:fillRect/>
+          </a:stretch>
+        </p:blipFill>
         <p:spPr>
           <a:xfrm>
             <a:off x="990600" y="8667750"/>
             <a:ext cx="1947863" cy="2720824"/>
           </a:xfrm>
-          <a:prstGeom prst="roundRect">
-            <a:avLst>
-              <a:gd name="adj" fmla="val 6846"/>
-            </a:avLst>
-          </a:prstGeom>
-          <a:solidFill>
-            <a:srgbClr val="E1F0F4"/>
-          </a:solidFill>
-          <a:ln w="12700">
-            <a:solidFill>
-              <a:srgbClr val="E1F0F4">
-                <a:alpha val="0"/>
-              </a:srgbClr>
-            </a:solidFill>
-            <a:prstDash val="solid"/>
-          </a:ln>
+          <a:prstGeom prst="rect">
+            <a:avLst/>
+          </a:prstGeom>
           <a:effectLst>
             <a:outerShdw sx="100000" sy="100000" kx="0" ky="0" algn="bl" rotWithShape="0" blurRad="152400" dist="76200" dir="5400000">
               <a:srgbClr val="000000">
@@ -8073,76 +7438,29 @@
             </a:outerShdw>
           </a:effectLst>
         </p:spPr>
-      </p:sp>
-      <p:sp>
-        <p:nvSpPr>
-          <p:cNvPr id="16" name="Text 14"/>
-          <p:cNvSpPr txBox="1"/>
-          <p:nvPr/>
-        </p:nvSpPr>
-        <p:spPr>
-          <a:xfrm>
-            <a:off x="990600" y="8667750"/>
-            <a:ext cx="1947863" cy="2720824"/>
-          </a:xfrm>
-          <a:prstGeom prst="rect">
-            <a:avLst/>
-          </a:prstGeom>
-          <a:noFill/>
-          <a:ln/>
-        </p:spPr>
-        <p:txBody>
-          <a:bodyPr wrap="square" lIns="0" tIns="0" rIns="0" bIns="0" rtlCol="0" anchor="ctr"/>
-          <a:lstStyle/>
-          <a:p>
-            <a:pPr algn="ctr" indent="0" marL="0">
-              <a:lnSpc>
-                <a:spcPct val="115000"/>
-              </a:lnSpc>
-              <a:buNone/>
-            </a:pPr>
-            <a:r>
-              <a:rPr lang="en-US" sz="1700" dirty="0">
-                <a:solidFill>
-                  <a:srgbClr val="52717F"/>
-                </a:solidFill>
-                <a:latin typeface="Inter" pitchFamily="34" charset="0"/>
-                <a:ea typeface="Inter" pitchFamily="34" charset="-122"/>
-                <a:cs typeface="Inter" pitchFamily="34" charset="-120"/>
-              </a:rPr>
-              <a:t>Carta 1</a:t>
-            </a:r>
-            <a:endParaRPr lang="en-US" sz="1700" dirty="0"/>
-          </a:p>
-        </p:txBody>
-      </p:sp>
-      <p:sp>
-        <p:nvSpPr>
-          <p:cNvPr id="17" name="Shape 15"/>
-          <p:cNvSpPr/>
-          <p:nvPr/>
-        </p:nvSpPr>
+      </p:pic>
+      <p:pic>
+        <p:nvPicPr>
+          <p:cNvPr id="16" name="Image 1" descr="/tmp/claude-0/-home-user/b9afdd5d-e7a3-5d00-bfc6-d85d45049058/scratchpad/canva/hueco-carta.png">    </p:cNvPr>
+          <p:cNvPicPr>
+            <a:picLocks noChangeAspect="1"/>
+          </p:cNvPicPr>
+          <p:nvPr/>
+        </p:nvPicPr>
+        <p:blipFill>
+          <a:blip r:embed="rId3"/>
+          <a:stretch>
+            <a:fillRect/>
+          </a:stretch>
+        </p:blipFill>
         <p:spPr>
           <a:xfrm>
             <a:off x="3109913" y="8667750"/>
             <a:ext cx="1947863" cy="2720824"/>
           </a:xfrm>
-          <a:prstGeom prst="roundRect">
-            <a:avLst>
-              <a:gd name="adj" fmla="val 6846"/>
-            </a:avLst>
-          </a:prstGeom>
-          <a:solidFill>
-            <a:srgbClr val="E1F0F4"/>
-          </a:solidFill>
-          <a:ln w="12700">
-            <a:solidFill>
-              <a:srgbClr val="E1F0F4">
-                <a:alpha val="0"/>
-              </a:srgbClr>
-            </a:solidFill>
-            <a:prstDash val="solid"/>
-          </a:ln>
+          <a:prstGeom prst="rect">
+            <a:avLst/>
+          </a:prstGeom>
           <a:effectLst>
             <a:outerShdw sx="100000" sy="100000" kx="0" ky="0" algn="bl" rotWithShape="0" blurRad="152400" dist="76200" dir="5400000">
               <a:srgbClr val="000000">
@@ -8151,76 +7469,29 @@
             </a:outerShdw>
           </a:effectLst>
         </p:spPr>
-      </p:sp>
-      <p:sp>
-        <p:nvSpPr>
-          <p:cNvPr id="18" name="Text 16"/>
-          <p:cNvSpPr txBox="1"/>
-          <p:nvPr/>
-        </p:nvSpPr>
-        <p:spPr>
-          <a:xfrm>
-            <a:off x="3109913" y="8667750"/>
-            <a:ext cx="1947863" cy="2720824"/>
-          </a:xfrm>
-          <a:prstGeom prst="rect">
-            <a:avLst/>
-          </a:prstGeom>
-          <a:noFill/>
-          <a:ln/>
-        </p:spPr>
-        <p:txBody>
-          <a:bodyPr wrap="square" lIns="0" tIns="0" rIns="0" bIns="0" rtlCol="0" anchor="ctr"/>
-          <a:lstStyle/>
-          <a:p>
-            <a:pPr algn="ctr" indent="0" marL="0">
-              <a:lnSpc>
-                <a:spcPct val="115000"/>
-              </a:lnSpc>
-              <a:buNone/>
-            </a:pPr>
-            <a:r>
-              <a:rPr lang="en-US" sz="1700" dirty="0">
-                <a:solidFill>
-                  <a:srgbClr val="52717F"/>
-                </a:solidFill>
-                <a:latin typeface="Inter" pitchFamily="34" charset="0"/>
-                <a:ea typeface="Inter" pitchFamily="34" charset="-122"/>
-                <a:cs typeface="Inter" pitchFamily="34" charset="-120"/>
-              </a:rPr>
-              <a:t>Carta 2</a:t>
-            </a:r>
-            <a:endParaRPr lang="en-US" sz="1700" dirty="0"/>
-          </a:p>
-        </p:txBody>
-      </p:sp>
-      <p:sp>
-        <p:nvSpPr>
-          <p:cNvPr id="19" name="Shape 17"/>
-          <p:cNvSpPr/>
-          <p:nvPr/>
-        </p:nvSpPr>
+      </p:pic>
+      <p:pic>
+        <p:nvPicPr>
+          <p:cNvPr id="17" name="Image 2" descr="/tmp/claude-0/-home-user/b9afdd5d-e7a3-5d00-bfc6-d85d45049058/scratchpad/canva/hueco-carta.png">    </p:cNvPr>
+          <p:cNvPicPr>
+            <a:picLocks noChangeAspect="1"/>
+          </p:cNvPicPr>
+          <p:nvPr/>
+        </p:nvPicPr>
+        <p:blipFill>
+          <a:blip r:embed="rId4"/>
+          <a:stretch>
+            <a:fillRect/>
+          </a:stretch>
+        </p:blipFill>
         <p:spPr>
           <a:xfrm>
             <a:off x="5229225" y="8667750"/>
             <a:ext cx="1947863" cy="2720824"/>
           </a:xfrm>
-          <a:prstGeom prst="roundRect">
-            <a:avLst>
-              <a:gd name="adj" fmla="val 6846"/>
-            </a:avLst>
-          </a:prstGeom>
-          <a:solidFill>
-            <a:srgbClr val="E1F0F4"/>
-          </a:solidFill>
-          <a:ln w="12700">
-            <a:solidFill>
-              <a:srgbClr val="E1F0F4">
-                <a:alpha val="0"/>
-              </a:srgbClr>
-            </a:solidFill>
-            <a:prstDash val="solid"/>
-          </a:ln>
+          <a:prstGeom prst="rect">
+            <a:avLst/>
+          </a:prstGeom>
           <a:effectLst>
             <a:outerShdw sx="100000" sy="100000" kx="0" ky="0" algn="bl" rotWithShape="0" blurRad="152400" dist="76200" dir="5400000">
               <a:srgbClr val="000000">
@@ -8229,76 +7500,29 @@
             </a:outerShdw>
           </a:effectLst>
         </p:spPr>
-      </p:sp>
-      <p:sp>
-        <p:nvSpPr>
-          <p:cNvPr id="20" name="Text 18"/>
-          <p:cNvSpPr txBox="1"/>
-          <p:nvPr/>
-        </p:nvSpPr>
-        <p:spPr>
-          <a:xfrm>
-            <a:off x="5229225" y="8667750"/>
-            <a:ext cx="1947863" cy="2720824"/>
-          </a:xfrm>
-          <a:prstGeom prst="rect">
-            <a:avLst/>
-          </a:prstGeom>
-          <a:noFill/>
-          <a:ln/>
-        </p:spPr>
-        <p:txBody>
-          <a:bodyPr wrap="square" lIns="0" tIns="0" rIns="0" bIns="0" rtlCol="0" anchor="ctr"/>
-          <a:lstStyle/>
-          <a:p>
-            <a:pPr algn="ctr" indent="0" marL="0">
-              <a:lnSpc>
-                <a:spcPct val="115000"/>
-              </a:lnSpc>
-              <a:buNone/>
-            </a:pPr>
-            <a:r>
-              <a:rPr lang="en-US" sz="1700" dirty="0">
-                <a:solidFill>
-                  <a:srgbClr val="52717F"/>
-                </a:solidFill>
-                <a:latin typeface="Inter" pitchFamily="34" charset="0"/>
-                <a:ea typeface="Inter" pitchFamily="34" charset="-122"/>
-                <a:cs typeface="Inter" pitchFamily="34" charset="-120"/>
-              </a:rPr>
-              <a:t>Carta 3</a:t>
-            </a:r>
-            <a:endParaRPr lang="en-US" sz="1700" dirty="0"/>
-          </a:p>
-        </p:txBody>
-      </p:sp>
-      <p:sp>
-        <p:nvSpPr>
-          <p:cNvPr id="21" name="Shape 19"/>
-          <p:cNvSpPr/>
-          <p:nvPr/>
-        </p:nvSpPr>
+      </p:pic>
+      <p:pic>
+        <p:nvPicPr>
+          <p:cNvPr id="18" name="Image 3" descr="/tmp/claude-0/-home-user/b9afdd5d-e7a3-5d00-bfc6-d85d45049058/scratchpad/canva/hueco-carta.png">    </p:cNvPr>
+          <p:cNvPicPr>
+            <a:picLocks noChangeAspect="1"/>
+          </p:cNvPicPr>
+          <p:nvPr/>
+        </p:nvPicPr>
+        <p:blipFill>
+          <a:blip r:embed="rId5"/>
+          <a:stretch>
+            <a:fillRect/>
+          </a:stretch>
+        </p:blipFill>
         <p:spPr>
           <a:xfrm>
             <a:off x="7348538" y="8667750"/>
             <a:ext cx="1947863" cy="2720824"/>
           </a:xfrm>
-          <a:prstGeom prst="roundRect">
-            <a:avLst>
-              <a:gd name="adj" fmla="val 6846"/>
-            </a:avLst>
-          </a:prstGeom>
-          <a:solidFill>
-            <a:srgbClr val="E1F0F4"/>
-          </a:solidFill>
-          <a:ln w="12700">
-            <a:solidFill>
-              <a:srgbClr val="E1F0F4">
-                <a:alpha val="0"/>
-              </a:srgbClr>
-            </a:solidFill>
-            <a:prstDash val="solid"/>
-          </a:ln>
+          <a:prstGeom prst="rect">
+            <a:avLst/>
+          </a:prstGeom>
           <a:effectLst>
             <a:outerShdw sx="100000" sy="100000" kx="0" ky="0" algn="bl" rotWithShape="0" blurRad="152400" dist="76200" dir="5400000">
               <a:srgbClr val="000000">
@@ -8307,52 +7531,10 @@
             </a:outerShdw>
           </a:effectLst>
         </p:spPr>
-      </p:sp>
-      <p:sp>
-        <p:nvSpPr>
-          <p:cNvPr id="22" name="Text 20"/>
-          <p:cNvSpPr txBox="1"/>
-          <p:nvPr/>
-        </p:nvSpPr>
-        <p:spPr>
-          <a:xfrm>
-            <a:off x="7348538" y="8667750"/>
-            <a:ext cx="1947863" cy="2720824"/>
-          </a:xfrm>
-          <a:prstGeom prst="rect">
-            <a:avLst/>
-          </a:prstGeom>
-          <a:noFill/>
-          <a:ln/>
-        </p:spPr>
-        <p:txBody>
-          <a:bodyPr wrap="square" lIns="0" tIns="0" rIns="0" bIns="0" rtlCol="0" anchor="ctr"/>
-          <a:lstStyle/>
-          <a:p>
-            <a:pPr algn="ctr" indent="0" marL="0">
-              <a:lnSpc>
-                <a:spcPct val="115000"/>
-              </a:lnSpc>
-              <a:buNone/>
-            </a:pPr>
-            <a:r>
-              <a:rPr lang="en-US" sz="1700" dirty="0">
-                <a:solidFill>
-                  <a:srgbClr val="52717F"/>
-                </a:solidFill>
-                <a:latin typeface="Inter" pitchFamily="34" charset="0"/>
-                <a:ea typeface="Inter" pitchFamily="34" charset="-122"/>
-                <a:cs typeface="Inter" pitchFamily="34" charset="-120"/>
-              </a:rPr>
-              <a:t>Carta 4</a:t>
-            </a:r>
-            <a:endParaRPr lang="en-US" sz="1700" dirty="0"/>
-          </a:p>
-        </p:txBody>
-      </p:sp>
-      <p:sp>
-        <p:nvSpPr>
-          <p:cNvPr id="23" name="Text 21"/>
+      </p:pic>
+      <p:sp>
+        <p:nvSpPr>
+          <p:cNvPr id="19" name="Text 13"/>
           <p:cNvSpPr txBox="1"/>
           <p:nvPr/>
         </p:nvSpPr>
@@ -8394,7 +7576,7 @@
       </p:sp>
       <p:sp>
         <p:nvSpPr>
-          <p:cNvPr id="24" name="Shape 22"/>
+          <p:cNvPr id="20" name="Shape 14"/>
           <p:cNvSpPr/>
           <p:nvPr/>
         </p:nvSpPr>
@@ -8423,7 +7605,7 @@
       </p:sp>
       <p:sp>
         <p:nvSpPr>
-          <p:cNvPr id="25" name="Text 23"/>
+          <p:cNvPr id="21" name="Text 15"/>
           <p:cNvSpPr txBox="1"/>
           <p:nvPr/>
         </p:nvSpPr>

</xml_diff>